<commit_message>
Añade formas femeninas a los verbos, más interrogativos y autoría
- Verbos: nosotros/nosotras, vosotros/vosotras y ellos/ellas/Uds. en
  vez de solo la forma masculina, en las cinco tablas de conjugación.
- Interrogativos: añade "de dónde" y "adónde".
- Autoría: pie de página con "© Ángel Luis Acosta González" en todas
  las diapositivas de contenido, línea de crédito en la portada, y
  firma personal ("— Ángel Luis Acosta González, tu profesor de
  español") en el cierre.
</commit_message>
<xml_diff>
--- a/docencia-espanol/materiales/presentaciones/nuevo-espanol-en-marcha-1_unidad1.pptx
+++ b/docencia-espanol/materiales/presentaciones/nuevo-espanol-en-marcha-1_unidad1.pptx
@@ -2628,8 +2628,8 @@
         </p:nvSpPr>
         <p:spPr>
           <a:xfrm>
-            <a:off x="822960" y="6217920"/>
-            <a:ext cx="10058400" cy="365760"/>
+            <a:off x="822960" y="6080760"/>
+            <a:ext cx="10058400" cy="320040"/>
           </a:xfrm>
           <a:prstGeom prst="rect">
             <a:avLst/>
@@ -2656,6 +2656,45 @@
               <a:t>Español → Ruso · Plantilla genérica para cualquier alumno</a:t>
             </a:r>
             <a:endParaRPr lang="en-US" sz="1100" dirty="0"/>
+          </a:p>
+        </p:txBody>
+      </p:sp>
+      <p:sp>
+        <p:nvSpPr>
+          <p:cNvPr id="18" name="Text 16"/>
+          <p:cNvSpPr/>
+          <p:nvPr/>
+        </p:nvSpPr>
+        <p:spPr>
+          <a:xfrm>
+            <a:off x="822960" y="6419088"/>
+            <a:ext cx="10058400" cy="274320"/>
+          </a:xfrm>
+          <a:prstGeom prst="rect">
+            <a:avLst/>
+          </a:prstGeom>
+          <a:noFill/>
+          <a:ln/>
+        </p:spPr>
+        <p:txBody>
+          <a:bodyPr wrap="square" lIns="0" tIns="0" rIns="0" bIns="0" rtlCol="0" anchor="ctr"/>
+          <a:lstStyle/>
+          <a:p>
+            <a:pPr indent="0" marL="0">
+              <a:buNone/>
+            </a:pPr>
+            <a:r>
+              <a:rPr lang="en-US" sz="1000" i="1" dirty="0">
+                <a:solidFill>
+                  <a:srgbClr val="6E7BB0"/>
+                </a:solidFill>
+                <a:latin typeface="Calibri" pitchFamily="34" charset="0"/>
+                <a:ea typeface="Calibri" pitchFamily="34" charset="-122"/>
+                <a:cs typeface="Calibri" pitchFamily="34" charset="-120"/>
+              </a:rPr>
+              <a:t>Material elaborado por Ángel Luis Acosta González</a:t>
+            </a:r>
+            <a:endParaRPr lang="en-US" sz="1000" dirty="0"/>
           </a:p>
         </p:txBody>
       </p:sp>
@@ -5052,6 +5091,45 @@
           </a:p>
         </p:txBody>
       </p:sp>
+      <p:sp>
+        <p:nvSpPr>
+          <p:cNvPr id="66" name="Text 64"/>
+          <p:cNvSpPr/>
+          <p:nvPr/>
+        </p:nvSpPr>
+        <p:spPr>
+          <a:xfrm>
+            <a:off x="7985455" y="6473952"/>
+            <a:ext cx="3657600" cy="274320"/>
+          </a:xfrm>
+          <a:prstGeom prst="rect">
+            <a:avLst/>
+          </a:prstGeom>
+          <a:noFill/>
+          <a:ln/>
+        </p:spPr>
+        <p:txBody>
+          <a:bodyPr wrap="square" lIns="0" tIns="0" rIns="0" bIns="0" rtlCol="0" anchor="ctr"/>
+          <a:lstStyle/>
+          <a:p>
+            <a:pPr algn="r" indent="0" marL="0">
+              <a:buNone/>
+            </a:pPr>
+            <a:r>
+              <a:rPr lang="en-US" sz="900" dirty="0">
+                <a:solidFill>
+                  <a:srgbClr val="5C6690"/>
+                </a:solidFill>
+                <a:latin typeface="Calibri" pitchFamily="34" charset="0"/>
+                <a:ea typeface="Calibri" pitchFamily="34" charset="-122"/>
+                <a:cs typeface="Calibri" pitchFamily="34" charset="-120"/>
+              </a:rPr>
+              <a:t>© Ángel Luis Acosta González</a:t>
+            </a:r>
+            <a:endParaRPr lang="en-US" sz="900" dirty="0"/>
+          </a:p>
+        </p:txBody>
+      </p:sp>
     </p:spTree>
   </p:cSld>
   <p:clrMapOvr>
@@ -7298,6 +7376,45 @@
           </a:p>
         </p:txBody>
       </p:sp>
+      <p:sp>
+        <p:nvSpPr>
+          <p:cNvPr id="62" name="Text 60"/>
+          <p:cNvSpPr/>
+          <p:nvPr/>
+        </p:nvSpPr>
+        <p:spPr>
+          <a:xfrm>
+            <a:off x="7985455" y="6473952"/>
+            <a:ext cx="3657600" cy="274320"/>
+          </a:xfrm>
+          <a:prstGeom prst="rect">
+            <a:avLst/>
+          </a:prstGeom>
+          <a:noFill/>
+          <a:ln/>
+        </p:spPr>
+        <p:txBody>
+          <a:bodyPr wrap="square" lIns="0" tIns="0" rIns="0" bIns="0" rtlCol="0" anchor="ctr"/>
+          <a:lstStyle/>
+          <a:p>
+            <a:pPr algn="r" indent="0" marL="0">
+              <a:buNone/>
+            </a:pPr>
+            <a:r>
+              <a:rPr lang="en-US" sz="900" dirty="0">
+                <a:solidFill>
+                  <a:srgbClr val="5C6690"/>
+                </a:solidFill>
+                <a:latin typeface="Calibri" pitchFamily="34" charset="0"/>
+                <a:ea typeface="Calibri" pitchFamily="34" charset="-122"/>
+                <a:cs typeface="Calibri" pitchFamily="34" charset="-120"/>
+              </a:rPr>
+              <a:t>© Ángel Luis Acosta González</a:t>
+            </a:r>
+            <a:endParaRPr lang="en-US" sz="900" dirty="0"/>
+          </a:p>
+        </p:txBody>
+      </p:sp>
     </p:spTree>
   </p:cSld>
   <p:clrMapOvr>
@@ -9544,6 +9661,45 @@
           </a:p>
         </p:txBody>
       </p:sp>
+      <p:sp>
+        <p:nvSpPr>
+          <p:cNvPr id="62" name="Text 60"/>
+          <p:cNvSpPr/>
+          <p:nvPr/>
+        </p:nvSpPr>
+        <p:spPr>
+          <a:xfrm>
+            <a:off x="7985455" y="6473952"/>
+            <a:ext cx="3657600" cy="274320"/>
+          </a:xfrm>
+          <a:prstGeom prst="rect">
+            <a:avLst/>
+          </a:prstGeom>
+          <a:noFill/>
+          <a:ln/>
+        </p:spPr>
+        <p:txBody>
+          <a:bodyPr wrap="square" lIns="0" tIns="0" rIns="0" bIns="0" rtlCol="0" anchor="ctr"/>
+          <a:lstStyle/>
+          <a:p>
+            <a:pPr algn="r" indent="0" marL="0">
+              <a:buNone/>
+            </a:pPr>
+            <a:r>
+              <a:rPr lang="en-US" sz="900" dirty="0">
+                <a:solidFill>
+                  <a:srgbClr val="5C6690"/>
+                </a:solidFill>
+                <a:latin typeface="Calibri" pitchFamily="34" charset="0"/>
+                <a:ea typeface="Calibri" pitchFamily="34" charset="-122"/>
+                <a:cs typeface="Calibri" pitchFamily="34" charset="-120"/>
+              </a:rPr>
+              <a:t>© Ángel Luis Acosta González</a:t>
+            </a:r>
+            <a:endParaRPr lang="en-US" sz="900" dirty="0"/>
+          </a:p>
+        </p:txBody>
+      </p:sp>
     </p:spTree>
   </p:cSld>
   <p:clrMapOvr>
@@ -9964,7 +10120,7 @@
                 <a:ea typeface="Calibri" pitchFamily="34" charset="-122"/>
                 <a:cs typeface="Calibri" pitchFamily="34" charset="-120"/>
               </a:rPr>
-              <a:t>nosotros  somos</a:t>
+              <a:t>nosotros/nosotras  somos</a:t>
             </a:r>
             <a:endParaRPr lang="en-US" sz="1100" dirty="0"/>
           </a:p>
@@ -9987,7 +10143,7 @@
                 <a:ea typeface="Calibri" pitchFamily="34" charset="-122"/>
                 <a:cs typeface="Calibri" pitchFamily="34" charset="-120"/>
               </a:rPr>
-              <a:t>vosotros  sois</a:t>
+              <a:t>vosotros/vosotras  sois</a:t>
             </a:r>
             <a:endParaRPr lang="en-US" sz="1100" dirty="0"/>
           </a:p>
@@ -10010,7 +10166,7 @@
                 <a:ea typeface="Calibri" pitchFamily="34" charset="-122"/>
                 <a:cs typeface="Calibri" pitchFamily="34" charset="-120"/>
               </a:rPr>
-              <a:t>ellos/Uds.  son</a:t>
+              <a:t>ellos/ellas/Uds.  son</a:t>
             </a:r>
             <a:endParaRPr lang="en-US" sz="1100" dirty="0"/>
           </a:p>
@@ -10287,7 +10443,7 @@
                 <a:ea typeface="Calibri" pitchFamily="34" charset="-122"/>
                 <a:cs typeface="Calibri" pitchFamily="34" charset="-120"/>
               </a:rPr>
-              <a:t>nosotros  tenemos</a:t>
+              <a:t>nosotros/nosotras  tenemos</a:t>
             </a:r>
             <a:endParaRPr lang="en-US" sz="1100" dirty="0"/>
           </a:p>
@@ -10310,7 +10466,7 @@
                 <a:ea typeface="Calibri" pitchFamily="34" charset="-122"/>
                 <a:cs typeface="Calibri" pitchFamily="34" charset="-120"/>
               </a:rPr>
-              <a:t>vosotros  tenéis</a:t>
+              <a:t>vosotros/vosotras  tenéis</a:t>
             </a:r>
             <a:endParaRPr lang="en-US" sz="1100" dirty="0"/>
           </a:p>
@@ -10333,7 +10489,7 @@
                 <a:ea typeface="Calibri" pitchFamily="34" charset="-122"/>
                 <a:cs typeface="Calibri" pitchFamily="34" charset="-120"/>
               </a:rPr>
-              <a:t>ellos/Uds.  tienen</a:t>
+              <a:t>ellos/ellas/Uds.  tienen</a:t>
             </a:r>
             <a:endParaRPr lang="en-US" sz="1100" dirty="0"/>
           </a:p>
@@ -10610,7 +10766,7 @@
                 <a:ea typeface="Calibri" pitchFamily="34" charset="-122"/>
                 <a:cs typeface="Calibri" pitchFamily="34" charset="-120"/>
               </a:rPr>
-              <a:t>nosotros  trabajamos</a:t>
+              <a:t>nosotros/nosotras  trabajamos</a:t>
             </a:r>
             <a:endParaRPr lang="en-US" sz="1100" dirty="0"/>
           </a:p>
@@ -10633,7 +10789,7 @@
                 <a:ea typeface="Calibri" pitchFamily="34" charset="-122"/>
                 <a:cs typeface="Calibri" pitchFamily="34" charset="-120"/>
               </a:rPr>
-              <a:t>vosotros  trabajáis</a:t>
+              <a:t>vosotros/vosotras  trabajáis</a:t>
             </a:r>
             <a:endParaRPr lang="en-US" sz="1100" dirty="0"/>
           </a:p>
@@ -10656,7 +10812,7 @@
                 <a:ea typeface="Calibri" pitchFamily="34" charset="-122"/>
                 <a:cs typeface="Calibri" pitchFamily="34" charset="-120"/>
               </a:rPr>
-              <a:t>ellos/Uds.  trabajan</a:t>
+              <a:t>ellos/ellas/Uds.  trabajan</a:t>
             </a:r>
             <a:endParaRPr lang="en-US" sz="1100" dirty="0"/>
           </a:p>
@@ -10933,7 +11089,7 @@
                 <a:ea typeface="Calibri" pitchFamily="34" charset="-122"/>
                 <a:cs typeface="Calibri" pitchFamily="34" charset="-120"/>
               </a:rPr>
-              <a:t>nosotros  comemos</a:t>
+              <a:t>nosotros/nosotras  comemos</a:t>
             </a:r>
             <a:endParaRPr lang="en-US" sz="1100" dirty="0"/>
           </a:p>
@@ -10956,7 +11112,7 @@
                 <a:ea typeface="Calibri" pitchFamily="34" charset="-122"/>
                 <a:cs typeface="Calibri" pitchFamily="34" charset="-120"/>
               </a:rPr>
-              <a:t>vosotros  coméis</a:t>
+              <a:t>vosotros/vosotras  coméis</a:t>
             </a:r>
             <a:endParaRPr lang="en-US" sz="1100" dirty="0"/>
           </a:p>
@@ -10979,7 +11135,7 @@
                 <a:ea typeface="Calibri" pitchFamily="34" charset="-122"/>
                 <a:cs typeface="Calibri" pitchFamily="34" charset="-120"/>
               </a:rPr>
-              <a:t>ellos/Uds.  comen</a:t>
+              <a:t>ellos/ellas/Uds.  comen</a:t>
             </a:r>
             <a:endParaRPr lang="en-US" sz="1100" dirty="0"/>
           </a:p>
@@ -11256,7 +11412,7 @@
                 <a:ea typeface="Calibri" pitchFamily="34" charset="-122"/>
                 <a:cs typeface="Calibri" pitchFamily="34" charset="-120"/>
               </a:rPr>
-              <a:t>nosotros  vivimos</a:t>
+              <a:t>nosotros/nosotras  vivimos</a:t>
             </a:r>
             <a:endParaRPr lang="en-US" sz="1100" dirty="0"/>
           </a:p>
@@ -11279,7 +11435,7 @@
                 <a:ea typeface="Calibri" pitchFamily="34" charset="-122"/>
                 <a:cs typeface="Calibri" pitchFamily="34" charset="-120"/>
               </a:rPr>
-              <a:t>vosotros  vivís</a:t>
+              <a:t>vosotros/vosotras  vivís</a:t>
             </a:r>
             <a:endParaRPr lang="en-US" sz="1100" dirty="0"/>
           </a:p>
@@ -11302,7 +11458,7 @@
                 <a:ea typeface="Calibri" pitchFamily="34" charset="-122"/>
                 <a:cs typeface="Calibri" pitchFamily="34" charset="-120"/>
               </a:rPr>
-              <a:t>ellos/Uds.  viven</a:t>
+              <a:t>ellos/ellas/Uds.  viven</a:t>
             </a:r>
             <a:endParaRPr lang="en-US" sz="1100" dirty="0"/>
           </a:p>
@@ -11344,6 +11500,45 @@
               <a:t>Nuevo Español en Marcha 1 · Unidad 1 · Vocabulario visual</a:t>
             </a:r>
             <a:endParaRPr lang="en-US" sz="1000" dirty="0"/>
+          </a:p>
+        </p:txBody>
+      </p:sp>
+      <p:sp>
+        <p:nvSpPr>
+          <p:cNvPr id="36" name="Text 34"/>
+          <p:cNvSpPr/>
+          <p:nvPr/>
+        </p:nvSpPr>
+        <p:spPr>
+          <a:xfrm>
+            <a:off x="7985455" y="6473952"/>
+            <a:ext cx="3657600" cy="274320"/>
+          </a:xfrm>
+          <a:prstGeom prst="rect">
+            <a:avLst/>
+          </a:prstGeom>
+          <a:noFill/>
+          <a:ln/>
+        </p:spPr>
+        <p:txBody>
+          <a:bodyPr wrap="square" lIns="0" tIns="0" rIns="0" bIns="0" rtlCol="0" anchor="ctr"/>
+          <a:lstStyle/>
+          <a:p>
+            <a:pPr algn="r" indent="0" marL="0">
+              <a:buNone/>
+            </a:pPr>
+            <a:r>
+              <a:rPr lang="en-US" sz="900" dirty="0">
+                <a:solidFill>
+                  <a:srgbClr val="5C6690"/>
+                </a:solidFill>
+                <a:latin typeface="Calibri" pitchFamily="34" charset="0"/>
+                <a:ea typeface="Calibri" pitchFamily="34" charset="-122"/>
+                <a:cs typeface="Calibri" pitchFamily="34" charset="-120"/>
+              </a:rPr>
+              <a:t>© Ángel Luis Acosta González</a:t>
+            </a:r>
+            <a:endParaRPr lang="en-US" sz="900" dirty="0"/>
           </a:p>
         </p:txBody>
       </p:sp>
@@ -14163,6 +14358,45 @@
           </a:p>
         </p:txBody>
       </p:sp>
+      <p:sp>
+        <p:nvSpPr>
+          <p:cNvPr id="78" name="Text 76"/>
+          <p:cNvSpPr/>
+          <p:nvPr/>
+        </p:nvSpPr>
+        <p:spPr>
+          <a:xfrm>
+            <a:off x="7985455" y="6473952"/>
+            <a:ext cx="3657600" cy="274320"/>
+          </a:xfrm>
+          <a:prstGeom prst="rect">
+            <a:avLst/>
+          </a:prstGeom>
+          <a:noFill/>
+          <a:ln/>
+        </p:spPr>
+        <p:txBody>
+          <a:bodyPr wrap="square" lIns="0" tIns="0" rIns="0" bIns="0" rtlCol="0" anchor="ctr"/>
+          <a:lstStyle/>
+          <a:p>
+            <a:pPr algn="r" indent="0" marL="0">
+              <a:buNone/>
+            </a:pPr>
+            <a:r>
+              <a:rPr lang="en-US" sz="900" dirty="0">
+                <a:solidFill>
+                  <a:srgbClr val="5C6690"/>
+                </a:solidFill>
+                <a:latin typeface="Calibri" pitchFamily="34" charset="0"/>
+                <a:ea typeface="Calibri" pitchFamily="34" charset="-122"/>
+                <a:cs typeface="Calibri" pitchFamily="34" charset="-120"/>
+              </a:rPr>
+              <a:t>© Ángel Luis Acosta González</a:t>
+            </a:r>
+            <a:endParaRPr lang="en-US" sz="900" dirty="0"/>
+          </a:p>
+        </p:txBody>
+      </p:sp>
     </p:spTree>
   </p:cSld>
   <p:clrMapOvr>
@@ -14396,6 +14630,45 @@
         </p:nvSpPr>
         <p:spPr>
           <a:xfrm>
+            <a:off x="822960" y="5074920"/>
+            <a:ext cx="9784080" cy="365760"/>
+          </a:xfrm>
+          <a:prstGeom prst="rect">
+            <a:avLst/>
+          </a:prstGeom>
+          <a:noFill/>
+          <a:ln/>
+        </p:spPr>
+        <p:txBody>
+          <a:bodyPr wrap="square" lIns="0" tIns="0" rIns="0" bIns="0" rtlCol="0" anchor="ctr"/>
+          <a:lstStyle/>
+          <a:p>
+            <a:pPr indent="0" marL="0">
+              <a:buNone/>
+            </a:pPr>
+            <a:r>
+              <a:rPr lang="en-US" sz="1500" i="1" dirty="0">
+                <a:solidFill>
+                  <a:srgbClr val="F9E795"/>
+                </a:solidFill>
+                <a:latin typeface="Cambria" pitchFamily="34" charset="0"/>
+                <a:ea typeface="Cambria" pitchFamily="34" charset="-122"/>
+                <a:cs typeface="Cambria" pitchFamily="34" charset="-120"/>
+              </a:rPr>
+              <a:t>— Ángel Luis Acosta González, tu profesor de español</a:t>
+            </a:r>
+            <a:endParaRPr lang="en-US" sz="1500" dirty="0"/>
+          </a:p>
+        </p:txBody>
+      </p:sp>
+      <p:sp>
+        <p:nvSpPr>
+          <p:cNvPr id="8" name="Text 6"/>
+          <p:cNvSpPr/>
+          <p:nvPr/>
+        </p:nvSpPr>
+        <p:spPr>
+          <a:xfrm>
             <a:off x="822960" y="6217920"/>
             <a:ext cx="10058400" cy="365760"/>
           </a:xfrm>
@@ -16673,6 +16946,45 @@
           </a:p>
         </p:txBody>
       </p:sp>
+      <p:sp>
+        <p:nvSpPr>
+          <p:cNvPr id="62" name="Text 60"/>
+          <p:cNvSpPr/>
+          <p:nvPr/>
+        </p:nvSpPr>
+        <p:spPr>
+          <a:xfrm>
+            <a:off x="7985455" y="6473952"/>
+            <a:ext cx="3657600" cy="274320"/>
+          </a:xfrm>
+          <a:prstGeom prst="rect">
+            <a:avLst/>
+          </a:prstGeom>
+          <a:noFill/>
+          <a:ln/>
+        </p:spPr>
+        <p:txBody>
+          <a:bodyPr wrap="square" lIns="0" tIns="0" rIns="0" bIns="0" rtlCol="0" anchor="ctr"/>
+          <a:lstStyle/>
+          <a:p>
+            <a:pPr algn="r" indent="0" marL="0">
+              <a:buNone/>
+            </a:pPr>
+            <a:r>
+              <a:rPr lang="en-US" sz="900" dirty="0">
+                <a:solidFill>
+                  <a:srgbClr val="5C6690"/>
+                </a:solidFill>
+                <a:latin typeface="Calibri" pitchFamily="34" charset="0"/>
+                <a:ea typeface="Calibri" pitchFamily="34" charset="-122"/>
+                <a:cs typeface="Calibri" pitchFamily="34" charset="-120"/>
+              </a:rPr>
+              <a:t>© Ángel Luis Acosta González</a:t>
+            </a:r>
+            <a:endParaRPr lang="en-US" sz="900" dirty="0"/>
+          </a:p>
+        </p:txBody>
+      </p:sp>
     </p:spTree>
   </p:cSld>
   <p:clrMapOvr>
@@ -18478,6 +18790,45 @@
           </a:p>
         </p:txBody>
       </p:sp>
+      <p:sp>
+        <p:nvSpPr>
+          <p:cNvPr id="50" name="Text 48"/>
+          <p:cNvSpPr/>
+          <p:nvPr/>
+        </p:nvSpPr>
+        <p:spPr>
+          <a:xfrm>
+            <a:off x="7985455" y="6473952"/>
+            <a:ext cx="3657600" cy="274320"/>
+          </a:xfrm>
+          <a:prstGeom prst="rect">
+            <a:avLst/>
+          </a:prstGeom>
+          <a:noFill/>
+          <a:ln/>
+        </p:spPr>
+        <p:txBody>
+          <a:bodyPr wrap="square" lIns="0" tIns="0" rIns="0" bIns="0" rtlCol="0" anchor="ctr"/>
+          <a:lstStyle/>
+          <a:p>
+            <a:pPr algn="r" indent="0" marL="0">
+              <a:buNone/>
+            </a:pPr>
+            <a:r>
+              <a:rPr lang="en-US" sz="900" dirty="0">
+                <a:solidFill>
+                  <a:srgbClr val="5C6690"/>
+                </a:solidFill>
+                <a:latin typeface="Calibri" pitchFamily="34" charset="0"/>
+                <a:ea typeface="Calibri" pitchFamily="34" charset="-122"/>
+                <a:cs typeface="Calibri" pitchFamily="34" charset="-120"/>
+              </a:rPr>
+              <a:t>© Ángel Luis Acosta González</a:t>
+            </a:r>
+            <a:endParaRPr lang="en-US" sz="900" dirty="0"/>
+          </a:p>
+        </p:txBody>
+      </p:sp>
     </p:spTree>
   </p:cSld>
   <p:clrMapOvr>
@@ -20136,6 +20487,45 @@
           </a:p>
         </p:txBody>
       </p:sp>
+      <p:sp>
+        <p:nvSpPr>
+          <p:cNvPr id="46" name="Text 44"/>
+          <p:cNvSpPr/>
+          <p:nvPr/>
+        </p:nvSpPr>
+        <p:spPr>
+          <a:xfrm>
+            <a:off x="7985455" y="6473952"/>
+            <a:ext cx="3657600" cy="274320"/>
+          </a:xfrm>
+          <a:prstGeom prst="rect">
+            <a:avLst/>
+          </a:prstGeom>
+          <a:noFill/>
+          <a:ln/>
+        </p:spPr>
+        <p:txBody>
+          <a:bodyPr wrap="square" lIns="0" tIns="0" rIns="0" bIns="0" rtlCol="0" anchor="ctr"/>
+          <a:lstStyle/>
+          <a:p>
+            <a:pPr algn="r" indent="0" marL="0">
+              <a:buNone/>
+            </a:pPr>
+            <a:r>
+              <a:rPr lang="en-US" sz="900" dirty="0">
+                <a:solidFill>
+                  <a:srgbClr val="5C6690"/>
+                </a:solidFill>
+                <a:latin typeface="Calibri" pitchFamily="34" charset="0"/>
+                <a:ea typeface="Calibri" pitchFamily="34" charset="-122"/>
+                <a:cs typeface="Calibri" pitchFamily="34" charset="-120"/>
+              </a:rPr>
+              <a:t>© Ángel Luis Acosta González</a:t>
+            </a:r>
+            <a:endParaRPr lang="en-US" sz="900" dirty="0"/>
+          </a:p>
+        </p:txBody>
+      </p:sp>
     </p:spTree>
   </p:cSld>
   <p:clrMapOvr>
@@ -20293,12 +20683,12 @@
         </p:nvSpPr>
         <p:spPr>
           <a:xfrm>
-            <a:off x="548640" y="2432304"/>
-            <a:ext cx="3563112" cy="1463040"/>
+            <a:off x="548640" y="1746504"/>
+            <a:ext cx="3563112" cy="1371600"/>
           </a:xfrm>
           <a:prstGeom prst="roundRect">
             <a:avLst>
-              <a:gd name="adj" fmla="val 5625"/>
+              <a:gd name="adj" fmla="val 6000"/>
             </a:avLst>
           </a:prstGeom>
           <a:solidFill>
@@ -20322,8 +20712,8 @@
         </p:nvSpPr>
         <p:spPr>
           <a:xfrm>
-            <a:off x="676656" y="2880360"/>
-            <a:ext cx="566928" cy="566928"/>
+            <a:off x="676656" y="2176272"/>
+            <a:ext cx="512064" cy="512064"/>
           </a:xfrm>
           <a:prstGeom prst="ellipse">
             <a:avLst/>
@@ -20342,8 +20732,8 @@
         </p:nvSpPr>
         <p:spPr>
           <a:xfrm>
-            <a:off x="676656" y="2880360"/>
-            <a:ext cx="566928" cy="566928"/>
+            <a:off x="676656" y="2176272"/>
+            <a:ext cx="512064" cy="512064"/>
           </a:xfrm>
           <a:prstGeom prst="rect">
             <a:avLst/>
@@ -20359,14 +20749,14 @@
               <a:buNone/>
             </a:pPr>
             <a:r>
-              <a:rPr lang="en-US" sz="2100" dirty="0">
+              <a:rPr lang="en-US" sz="1900" dirty="0">
                 <a:solidFill>
                   <a:srgbClr val="000000"/>
                 </a:solidFill>
               </a:rPr>
               <a:t>❓</a:t>
             </a:r>
-            <a:endParaRPr lang="en-US" sz="2100" dirty="0"/>
+            <a:endParaRPr lang="en-US" sz="1900" dirty="0"/>
           </a:p>
         </p:txBody>
       </p:sp>
@@ -20378,8 +20768,8 @@
         </p:nvSpPr>
         <p:spPr>
           <a:xfrm>
-            <a:off x="1371600" y="2478024"/>
-            <a:ext cx="2630424" cy="1371600"/>
+            <a:off x="1316736" y="1792224"/>
+            <a:ext cx="2685288" cy="1280160"/>
           </a:xfrm>
           <a:prstGeom prst="rect">
             <a:avLst/>
@@ -20398,7 +20788,7 @@
               <a:buNone/>
             </a:pPr>
             <a:r>
-              <a:rPr lang="en-US" sz="1700" b="1" dirty="0">
+              <a:rPr lang="en-US" sz="1500" b="1" dirty="0">
                 <a:solidFill>
                   <a:srgbClr val="2F3C7E"/>
                 </a:solidFill>
@@ -20408,7 +20798,7 @@
               </a:rPr>
               <a:t>qué</a:t>
             </a:r>
-            <a:endParaRPr lang="en-US" sz="1700" dirty="0"/>
+            <a:endParaRPr lang="en-US" sz="1500" dirty="0"/>
           </a:p>
           <a:p>
             <a:pPr indent="0" marL="0">
@@ -20418,7 +20808,7 @@
               <a:buNone/>
             </a:pPr>
             <a:r>
-              <a:rPr lang="en-US" sz="1200" dirty="0">
+              <a:rPr lang="en-US" sz="1100" dirty="0">
                 <a:solidFill>
                   <a:srgbClr val="5C6690"/>
                 </a:solidFill>
@@ -20428,7 +20818,7 @@
               </a:rPr>
               <a:t>что / какой</a:t>
             </a:r>
-            <a:endParaRPr lang="en-US" sz="1700" dirty="0"/>
+            <a:endParaRPr lang="en-US" sz="1500" dirty="0"/>
           </a:p>
         </p:txBody>
       </p:sp>
@@ -20440,12 +20830,12 @@
         </p:nvSpPr>
         <p:spPr>
           <a:xfrm>
-            <a:off x="4312920" y="2432304"/>
-            <a:ext cx="3563112" cy="1463040"/>
+            <a:off x="4312920" y="1746504"/>
+            <a:ext cx="3563112" cy="1371600"/>
           </a:xfrm>
           <a:prstGeom prst="roundRect">
             <a:avLst>
-              <a:gd name="adj" fmla="val 5625"/>
+              <a:gd name="adj" fmla="val 6000"/>
             </a:avLst>
           </a:prstGeom>
           <a:solidFill>
@@ -20469,8 +20859,8 @@
         </p:nvSpPr>
         <p:spPr>
           <a:xfrm>
-            <a:off x="4440936" y="2880360"/>
-            <a:ext cx="566928" cy="566928"/>
+            <a:off x="4440936" y="2176272"/>
+            <a:ext cx="512064" cy="512064"/>
           </a:xfrm>
           <a:prstGeom prst="ellipse">
             <a:avLst/>
@@ -20489,8 +20879,8 @@
         </p:nvSpPr>
         <p:spPr>
           <a:xfrm>
-            <a:off x="4440936" y="2880360"/>
-            <a:ext cx="566928" cy="566928"/>
+            <a:off x="4440936" y="2176272"/>
+            <a:ext cx="512064" cy="512064"/>
           </a:xfrm>
           <a:prstGeom prst="rect">
             <a:avLst/>
@@ -20506,14 +20896,14 @@
               <a:buNone/>
             </a:pPr>
             <a:r>
-              <a:rPr lang="en-US" sz="2100" dirty="0">
+              <a:rPr lang="en-US" sz="1900" dirty="0">
                 <a:solidFill>
                   <a:srgbClr val="000000"/>
                 </a:solidFill>
               </a:rPr>
               <a:t>📍</a:t>
             </a:r>
-            <a:endParaRPr lang="en-US" sz="2100" dirty="0"/>
+            <a:endParaRPr lang="en-US" sz="1900" dirty="0"/>
           </a:p>
         </p:txBody>
       </p:sp>
@@ -20525,8 +20915,8 @@
         </p:nvSpPr>
         <p:spPr>
           <a:xfrm>
-            <a:off x="5135880" y="2478024"/>
-            <a:ext cx="2630424" cy="1371600"/>
+            <a:off x="5081016" y="1792224"/>
+            <a:ext cx="2685288" cy="1280160"/>
           </a:xfrm>
           <a:prstGeom prst="rect">
             <a:avLst/>
@@ -20545,7 +20935,7 @@
               <a:buNone/>
             </a:pPr>
             <a:r>
-              <a:rPr lang="en-US" sz="1700" b="1" dirty="0">
+              <a:rPr lang="en-US" sz="1500" b="1" dirty="0">
                 <a:solidFill>
                   <a:srgbClr val="2F3C7E"/>
                 </a:solidFill>
@@ -20555,7 +20945,7 @@
               </a:rPr>
               <a:t>dónde</a:t>
             </a:r>
-            <a:endParaRPr lang="en-US" sz="1700" dirty="0"/>
+            <a:endParaRPr lang="en-US" sz="1500" dirty="0"/>
           </a:p>
           <a:p>
             <a:pPr indent="0" marL="0">
@@ -20565,7 +20955,7 @@
               <a:buNone/>
             </a:pPr>
             <a:r>
-              <a:rPr lang="en-US" sz="1200" dirty="0">
+              <a:rPr lang="en-US" sz="1100" dirty="0">
                 <a:solidFill>
                   <a:srgbClr val="5C6690"/>
                 </a:solidFill>
@@ -20575,7 +20965,7 @@
               </a:rPr>
               <a:t>где</a:t>
             </a:r>
-            <a:endParaRPr lang="en-US" sz="1700" dirty="0"/>
+            <a:endParaRPr lang="en-US" sz="1500" dirty="0"/>
           </a:p>
         </p:txBody>
       </p:sp>
@@ -20587,12 +20977,12 @@
         </p:nvSpPr>
         <p:spPr>
           <a:xfrm>
-            <a:off x="8077200" y="2432304"/>
-            <a:ext cx="3563112" cy="1463040"/>
+            <a:off x="8077200" y="1746504"/>
+            <a:ext cx="3563112" cy="1371600"/>
           </a:xfrm>
           <a:prstGeom prst="roundRect">
             <a:avLst>
-              <a:gd name="adj" fmla="val 5625"/>
+              <a:gd name="adj" fmla="val 6000"/>
             </a:avLst>
           </a:prstGeom>
           <a:solidFill>
@@ -20616,8 +21006,8 @@
         </p:nvSpPr>
         <p:spPr>
           <a:xfrm>
-            <a:off x="8205216" y="2880360"/>
-            <a:ext cx="566928" cy="566928"/>
+            <a:off x="8205216" y="2176272"/>
+            <a:ext cx="512064" cy="512064"/>
           </a:xfrm>
           <a:prstGeom prst="ellipse">
             <a:avLst/>
@@ -20636,8 +21026,8 @@
         </p:nvSpPr>
         <p:spPr>
           <a:xfrm>
-            <a:off x="8205216" y="2880360"/>
-            <a:ext cx="566928" cy="566928"/>
+            <a:off x="8205216" y="2176272"/>
+            <a:ext cx="512064" cy="512064"/>
           </a:xfrm>
           <a:prstGeom prst="rect">
             <a:avLst/>
@@ -20653,14 +21043,14 @@
               <a:buNone/>
             </a:pPr>
             <a:r>
-              <a:rPr lang="en-US" sz="2100" dirty="0">
+              <a:rPr lang="en-US" sz="1900" dirty="0">
                 <a:solidFill>
                   <a:srgbClr val="000000"/>
                 </a:solidFill>
               </a:rPr>
-              <a:t>🤔</a:t>
-            </a:r>
-            <a:endParaRPr lang="en-US" sz="2100" dirty="0"/>
+              <a:t>🧭</a:t>
+            </a:r>
+            <a:endParaRPr lang="en-US" sz="1900" dirty="0"/>
           </a:p>
         </p:txBody>
       </p:sp>
@@ -20672,8 +21062,8 @@
         </p:nvSpPr>
         <p:spPr>
           <a:xfrm>
-            <a:off x="8900160" y="2478024"/>
-            <a:ext cx="2630424" cy="1371600"/>
+            <a:off x="8845296" y="1792224"/>
+            <a:ext cx="2685288" cy="1280160"/>
           </a:xfrm>
           <a:prstGeom prst="rect">
             <a:avLst/>
@@ -20692,7 +21082,7 @@
               <a:buNone/>
             </a:pPr>
             <a:r>
-              <a:rPr lang="en-US" sz="1700" b="1" dirty="0">
+              <a:rPr lang="en-US" sz="1500" b="1" dirty="0">
                 <a:solidFill>
                   <a:srgbClr val="2F3C7E"/>
                 </a:solidFill>
@@ -20700,9 +21090,9 @@
                 <a:ea typeface="Calibri" pitchFamily="34" charset="-122"/>
                 <a:cs typeface="Calibri" pitchFamily="34" charset="-120"/>
               </a:rPr>
-              <a:t>cómo</a:t>
-            </a:r>
-            <a:endParaRPr lang="en-US" sz="1700" dirty="0"/>
+              <a:t>de dónde</a:t>
+            </a:r>
+            <a:endParaRPr lang="en-US" sz="1500" dirty="0"/>
           </a:p>
           <a:p>
             <a:pPr indent="0" marL="0">
@@ -20712,7 +21102,7 @@
               <a:buNone/>
             </a:pPr>
             <a:r>
-              <a:rPr lang="en-US" sz="1200" dirty="0">
+              <a:rPr lang="en-US" sz="1100" dirty="0">
                 <a:solidFill>
                   <a:srgbClr val="5C6690"/>
                 </a:solidFill>
@@ -20720,9 +21110,9 @@
                 <a:ea typeface="Calibri" pitchFamily="34" charset="-122"/>
                 <a:cs typeface="Calibri" pitchFamily="34" charset="-120"/>
               </a:rPr>
-              <a:t>как</a:t>
-            </a:r>
-            <a:endParaRPr lang="en-US" sz="1700" dirty="0"/>
+              <a:t>откуда</a:t>
+            </a:r>
+            <a:endParaRPr lang="en-US" sz="1500" dirty="0"/>
           </a:p>
         </p:txBody>
       </p:sp>
@@ -20734,12 +21124,12 @@
         </p:nvSpPr>
         <p:spPr>
           <a:xfrm>
-            <a:off x="548640" y="4078224"/>
-            <a:ext cx="3563112" cy="1463040"/>
+            <a:off x="548640" y="3300984"/>
+            <a:ext cx="3563112" cy="1371600"/>
           </a:xfrm>
           <a:prstGeom prst="roundRect">
             <a:avLst>
-              <a:gd name="adj" fmla="val 5625"/>
+              <a:gd name="adj" fmla="val 6000"/>
             </a:avLst>
           </a:prstGeom>
           <a:solidFill>
@@ -20763,8 +21153,8 @@
         </p:nvSpPr>
         <p:spPr>
           <a:xfrm>
-            <a:off x="676656" y="4526280"/>
-            <a:ext cx="566928" cy="566928"/>
+            <a:off x="676656" y="3730752"/>
+            <a:ext cx="512064" cy="512064"/>
           </a:xfrm>
           <a:prstGeom prst="ellipse">
             <a:avLst/>
@@ -20783,8 +21173,8 @@
         </p:nvSpPr>
         <p:spPr>
           <a:xfrm>
-            <a:off x="676656" y="4526280"/>
-            <a:ext cx="566928" cy="566928"/>
+            <a:off x="676656" y="3730752"/>
+            <a:ext cx="512064" cy="512064"/>
           </a:xfrm>
           <a:prstGeom prst="rect">
             <a:avLst/>
@@ -20800,14 +21190,14 @@
               <a:buNone/>
             </a:pPr>
             <a:r>
-              <a:rPr lang="en-US" sz="2100" dirty="0">
+              <a:rPr lang="en-US" sz="1900" dirty="0">
                 <a:solidFill>
                   <a:srgbClr val="000000"/>
                 </a:solidFill>
               </a:rPr>
-              <a:t>🔀</a:t>
-            </a:r>
-            <a:endParaRPr lang="en-US" sz="2100" dirty="0"/>
+              <a:t>➡️</a:t>
+            </a:r>
+            <a:endParaRPr lang="en-US" sz="1900" dirty="0"/>
           </a:p>
         </p:txBody>
       </p:sp>
@@ -20819,8 +21209,8 @@
         </p:nvSpPr>
         <p:spPr>
           <a:xfrm>
-            <a:off x="1371600" y="4123944"/>
-            <a:ext cx="2630424" cy="1371600"/>
+            <a:off x="1316736" y="3346704"/>
+            <a:ext cx="2685288" cy="1280160"/>
           </a:xfrm>
           <a:prstGeom prst="rect">
             <a:avLst/>
@@ -20839,7 +21229,7 @@
               <a:buNone/>
             </a:pPr>
             <a:r>
-              <a:rPr lang="en-US" sz="1700" b="1" dirty="0">
+              <a:rPr lang="en-US" sz="1500" b="1" dirty="0">
                 <a:solidFill>
                   <a:srgbClr val="2F3C7E"/>
                 </a:solidFill>
@@ -20847,9 +21237,9 @@
                 <a:ea typeface="Calibri" pitchFamily="34" charset="-122"/>
                 <a:cs typeface="Calibri" pitchFamily="34" charset="-120"/>
               </a:rPr>
-              <a:t>cuál</a:t>
-            </a:r>
-            <a:endParaRPr lang="en-US" sz="1700" dirty="0"/>
+              <a:t>adónde</a:t>
+            </a:r>
+            <a:endParaRPr lang="en-US" sz="1500" dirty="0"/>
           </a:p>
           <a:p>
             <a:pPr indent="0" marL="0">
@@ -20859,7 +21249,7 @@
               <a:buNone/>
             </a:pPr>
             <a:r>
-              <a:rPr lang="en-US" sz="1200" dirty="0">
+              <a:rPr lang="en-US" sz="1100" dirty="0">
                 <a:solidFill>
                   <a:srgbClr val="5C6690"/>
                 </a:solidFill>
@@ -20867,9 +21257,9 @@
                 <a:ea typeface="Calibri" pitchFamily="34" charset="-122"/>
                 <a:cs typeface="Calibri" pitchFamily="34" charset="-120"/>
               </a:rPr>
-              <a:t>какой (из вариантов)</a:t>
-            </a:r>
-            <a:endParaRPr lang="en-US" sz="1700" dirty="0"/>
+              <a:t>куда</a:t>
+            </a:r>
+            <a:endParaRPr lang="en-US" sz="1500" dirty="0"/>
           </a:p>
         </p:txBody>
       </p:sp>
@@ -20881,12 +21271,12 @@
         </p:nvSpPr>
         <p:spPr>
           <a:xfrm>
-            <a:off x="4312920" y="4078224"/>
-            <a:ext cx="3563112" cy="1463040"/>
+            <a:off x="4312920" y="3300984"/>
+            <a:ext cx="3563112" cy="1371600"/>
           </a:xfrm>
           <a:prstGeom prst="roundRect">
             <a:avLst>
-              <a:gd name="adj" fmla="val 5625"/>
+              <a:gd name="adj" fmla="val 6000"/>
             </a:avLst>
           </a:prstGeom>
           <a:solidFill>
@@ -20910,8 +21300,8 @@
         </p:nvSpPr>
         <p:spPr>
           <a:xfrm>
-            <a:off x="4440936" y="4526280"/>
-            <a:ext cx="566928" cy="566928"/>
+            <a:off x="4440936" y="3730752"/>
+            <a:ext cx="512064" cy="512064"/>
           </a:xfrm>
           <a:prstGeom prst="ellipse">
             <a:avLst/>
@@ -20930,8 +21320,8 @@
         </p:nvSpPr>
         <p:spPr>
           <a:xfrm>
-            <a:off x="4440936" y="4526280"/>
-            <a:ext cx="566928" cy="566928"/>
+            <a:off x="4440936" y="3730752"/>
+            <a:ext cx="512064" cy="512064"/>
           </a:xfrm>
           <a:prstGeom prst="rect">
             <a:avLst/>
@@ -20947,14 +21337,14 @@
               <a:buNone/>
             </a:pPr>
             <a:r>
-              <a:rPr lang="en-US" sz="2100" dirty="0">
+              <a:rPr lang="en-US" sz="1900" dirty="0">
                 <a:solidFill>
                   <a:srgbClr val="000000"/>
                 </a:solidFill>
               </a:rPr>
-              <a:t>🙋</a:t>
-            </a:r>
-            <a:endParaRPr lang="en-US" sz="2100" dirty="0"/>
+              <a:t>🤔</a:t>
+            </a:r>
+            <a:endParaRPr lang="en-US" sz="1900" dirty="0"/>
           </a:p>
         </p:txBody>
       </p:sp>
@@ -20966,8 +21356,8 @@
         </p:nvSpPr>
         <p:spPr>
           <a:xfrm>
-            <a:off x="5135880" y="4123944"/>
-            <a:ext cx="2630424" cy="1371600"/>
+            <a:off x="5081016" y="3346704"/>
+            <a:ext cx="2685288" cy="1280160"/>
           </a:xfrm>
           <a:prstGeom prst="rect">
             <a:avLst/>
@@ -20986,7 +21376,7 @@
               <a:buNone/>
             </a:pPr>
             <a:r>
-              <a:rPr lang="en-US" sz="1700" b="1" dirty="0">
+              <a:rPr lang="en-US" sz="1500" b="1" dirty="0">
                 <a:solidFill>
                   <a:srgbClr val="2F3C7E"/>
                 </a:solidFill>
@@ -20994,9 +21384,9 @@
                 <a:ea typeface="Calibri" pitchFamily="34" charset="-122"/>
                 <a:cs typeface="Calibri" pitchFamily="34" charset="-120"/>
               </a:rPr>
-              <a:t>quién / quiénes</a:t>
-            </a:r>
-            <a:endParaRPr lang="en-US" sz="1700" dirty="0"/>
+              <a:t>cómo</a:t>
+            </a:r>
+            <a:endParaRPr lang="en-US" sz="1500" dirty="0"/>
           </a:p>
           <a:p>
             <a:pPr indent="0" marL="0">
@@ -21006,7 +21396,7 @@
               <a:buNone/>
             </a:pPr>
             <a:r>
-              <a:rPr lang="en-US" sz="1200" dirty="0">
+              <a:rPr lang="en-US" sz="1100" dirty="0">
                 <a:solidFill>
                   <a:srgbClr val="5C6690"/>
                 </a:solidFill>
@@ -21014,9 +21404,9 @@
                 <a:ea typeface="Calibri" pitchFamily="34" charset="-122"/>
                 <a:cs typeface="Calibri" pitchFamily="34" charset="-120"/>
               </a:rPr>
-              <a:t>кто</a:t>
-            </a:r>
-            <a:endParaRPr lang="en-US" sz="1700" dirty="0"/>
+              <a:t>как</a:t>
+            </a:r>
+            <a:endParaRPr lang="en-US" sz="1500" dirty="0"/>
           </a:p>
         </p:txBody>
       </p:sp>
@@ -21028,12 +21418,12 @@
         </p:nvSpPr>
         <p:spPr>
           <a:xfrm>
-            <a:off x="8077200" y="4078224"/>
-            <a:ext cx="3563112" cy="1463040"/>
+            <a:off x="8077200" y="3300984"/>
+            <a:ext cx="3563112" cy="1371600"/>
           </a:xfrm>
           <a:prstGeom prst="roundRect">
             <a:avLst>
-              <a:gd name="adj" fmla="val 5625"/>
+              <a:gd name="adj" fmla="val 6000"/>
             </a:avLst>
           </a:prstGeom>
           <a:solidFill>
@@ -21057,8 +21447,8 @@
         </p:nvSpPr>
         <p:spPr>
           <a:xfrm>
-            <a:off x="8205216" y="4526280"/>
-            <a:ext cx="566928" cy="566928"/>
+            <a:off x="8205216" y="3730752"/>
+            <a:ext cx="512064" cy="512064"/>
           </a:xfrm>
           <a:prstGeom prst="ellipse">
             <a:avLst/>
@@ -21077,8 +21467,8 @@
         </p:nvSpPr>
         <p:spPr>
           <a:xfrm>
-            <a:off x="8205216" y="4526280"/>
-            <a:ext cx="566928" cy="566928"/>
+            <a:off x="8205216" y="3730752"/>
+            <a:ext cx="512064" cy="512064"/>
           </a:xfrm>
           <a:prstGeom prst="rect">
             <a:avLst/>
@@ -21094,27 +21484,321 @@
               <a:buNone/>
             </a:pPr>
             <a:r>
-              <a:rPr lang="en-US" sz="2100" dirty="0">
+              <a:rPr lang="en-US" sz="1900" dirty="0">
                 <a:solidFill>
                   <a:srgbClr val="000000"/>
                 </a:solidFill>
               </a:rPr>
+              <a:t>🔀</a:t>
+            </a:r>
+            <a:endParaRPr lang="en-US" sz="1900" dirty="0"/>
+          </a:p>
+        </p:txBody>
+      </p:sp>
+      <p:sp>
+        <p:nvSpPr>
+          <p:cNvPr id="28" name="Text 26"/>
+          <p:cNvSpPr/>
+          <p:nvPr/>
+        </p:nvSpPr>
+        <p:spPr>
+          <a:xfrm>
+            <a:off x="8845296" y="3346704"/>
+            <a:ext cx="2685288" cy="1280160"/>
+          </a:xfrm>
+          <a:prstGeom prst="rect">
+            <a:avLst/>
+          </a:prstGeom>
+          <a:noFill/>
+          <a:ln/>
+        </p:spPr>
+        <p:txBody>
+          <a:bodyPr wrap="square" lIns="0" tIns="0" rIns="0" bIns="0" rtlCol="0" anchor="ctr"/>
+          <a:lstStyle/>
+          <a:p>
+            <a:pPr indent="0" marL="0">
+              <a:lnSpc>
+                <a:spcPct val="105000"/>
+              </a:lnSpc>
+              <a:buNone/>
+            </a:pPr>
+            <a:r>
+              <a:rPr lang="en-US" sz="1500" b="1" dirty="0">
+                <a:solidFill>
+                  <a:srgbClr val="2F3C7E"/>
+                </a:solidFill>
+                <a:latin typeface="Calibri" pitchFamily="34" charset="0"/>
+                <a:ea typeface="Calibri" pitchFamily="34" charset="-122"/>
+                <a:cs typeface="Calibri" pitchFamily="34" charset="-120"/>
+              </a:rPr>
+              <a:t>cuál</a:t>
+            </a:r>
+            <a:endParaRPr lang="en-US" sz="1500" dirty="0"/>
+          </a:p>
+          <a:p>
+            <a:pPr indent="0" marL="0">
+              <a:lnSpc>
+                <a:spcPct val="105000"/>
+              </a:lnSpc>
+              <a:buNone/>
+            </a:pPr>
+            <a:r>
+              <a:rPr lang="en-US" sz="1100" dirty="0">
+                <a:solidFill>
+                  <a:srgbClr val="5C6690"/>
+                </a:solidFill>
+                <a:latin typeface="Calibri" pitchFamily="34" charset="0"/>
+                <a:ea typeface="Calibri" pitchFamily="34" charset="-122"/>
+                <a:cs typeface="Calibri" pitchFamily="34" charset="-120"/>
+              </a:rPr>
+              <a:t>какой (из вариантов)</a:t>
+            </a:r>
+            <a:endParaRPr lang="en-US" sz="1500" dirty="0"/>
+          </a:p>
+        </p:txBody>
+      </p:sp>
+      <p:sp>
+        <p:nvSpPr>
+          <p:cNvPr id="29" name="Shape 27"/>
+          <p:cNvSpPr/>
+          <p:nvPr/>
+        </p:nvSpPr>
+        <p:spPr>
+          <a:xfrm>
+            <a:off x="548640" y="4855464"/>
+            <a:ext cx="3563112" cy="1371600"/>
+          </a:xfrm>
+          <a:prstGeom prst="roundRect">
+            <a:avLst>
+              <a:gd name="adj" fmla="val 6000"/>
+            </a:avLst>
+          </a:prstGeom>
+          <a:solidFill>
+            <a:srgbClr val="F5F6FB"/>
+          </a:solidFill>
+          <a:ln/>
+          <a:effectLst>
+            <a:outerShdw sx="100000" sy="100000" kx="0" ky="0" algn="bl" rotWithShape="0" blurRad="76200" dist="38100" dir="5400000">
+              <a:srgbClr val="1B2340">
+                <a:alpha val="18000"/>
+              </a:srgbClr>
+            </a:outerShdw>
+          </a:effectLst>
+        </p:spPr>
+      </p:sp>
+      <p:sp>
+        <p:nvSpPr>
+          <p:cNvPr id="30" name="Shape 28"/>
+          <p:cNvSpPr/>
+          <p:nvPr/>
+        </p:nvSpPr>
+        <p:spPr>
+          <a:xfrm>
+            <a:off x="676656" y="5285232"/>
+            <a:ext cx="512064" cy="512064"/>
+          </a:xfrm>
+          <a:prstGeom prst="ellipse">
+            <a:avLst/>
+          </a:prstGeom>
+          <a:solidFill>
+            <a:srgbClr val="F96167"/>
+          </a:solidFill>
+          <a:ln/>
+        </p:spPr>
+      </p:sp>
+      <p:sp>
+        <p:nvSpPr>
+          <p:cNvPr id="31" name="Text 29"/>
+          <p:cNvSpPr/>
+          <p:nvPr/>
+        </p:nvSpPr>
+        <p:spPr>
+          <a:xfrm>
+            <a:off x="676656" y="5285232"/>
+            <a:ext cx="512064" cy="512064"/>
+          </a:xfrm>
+          <a:prstGeom prst="rect">
+            <a:avLst/>
+          </a:prstGeom>
+          <a:noFill/>
+          <a:ln/>
+        </p:spPr>
+        <p:txBody>
+          <a:bodyPr wrap="square" lIns="0" tIns="0" rIns="0" bIns="0" rtlCol="0" anchor="ctr"/>
+          <a:lstStyle/>
+          <a:p>
+            <a:pPr algn="ctr" indent="0" marL="0">
+              <a:buNone/>
+            </a:pPr>
+            <a:r>
+              <a:rPr lang="en-US" sz="1900" dirty="0">
+                <a:solidFill>
+                  <a:srgbClr val="000000"/>
+                </a:solidFill>
+              </a:rPr>
+              <a:t>🙋</a:t>
+            </a:r>
+            <a:endParaRPr lang="en-US" sz="1900" dirty="0"/>
+          </a:p>
+        </p:txBody>
+      </p:sp>
+      <p:sp>
+        <p:nvSpPr>
+          <p:cNvPr id="32" name="Text 30"/>
+          <p:cNvSpPr/>
+          <p:nvPr/>
+        </p:nvSpPr>
+        <p:spPr>
+          <a:xfrm>
+            <a:off x="1316736" y="4901184"/>
+            <a:ext cx="2685288" cy="1280160"/>
+          </a:xfrm>
+          <a:prstGeom prst="rect">
+            <a:avLst/>
+          </a:prstGeom>
+          <a:noFill/>
+          <a:ln/>
+        </p:spPr>
+        <p:txBody>
+          <a:bodyPr wrap="square" lIns="0" tIns="0" rIns="0" bIns="0" rtlCol="0" anchor="ctr"/>
+          <a:lstStyle/>
+          <a:p>
+            <a:pPr indent="0" marL="0">
+              <a:lnSpc>
+                <a:spcPct val="105000"/>
+              </a:lnSpc>
+              <a:buNone/>
+            </a:pPr>
+            <a:r>
+              <a:rPr lang="en-US" sz="1500" b="1" dirty="0">
+                <a:solidFill>
+                  <a:srgbClr val="2F3C7E"/>
+                </a:solidFill>
+                <a:latin typeface="Calibri" pitchFamily="34" charset="0"/>
+                <a:ea typeface="Calibri" pitchFamily="34" charset="-122"/>
+                <a:cs typeface="Calibri" pitchFamily="34" charset="-120"/>
+              </a:rPr>
+              <a:t>quién / quiénes</a:t>
+            </a:r>
+            <a:endParaRPr lang="en-US" sz="1500" dirty="0"/>
+          </a:p>
+          <a:p>
+            <a:pPr indent="0" marL="0">
+              <a:lnSpc>
+                <a:spcPct val="105000"/>
+              </a:lnSpc>
+              <a:buNone/>
+            </a:pPr>
+            <a:r>
+              <a:rPr lang="en-US" sz="1100" dirty="0">
+                <a:solidFill>
+                  <a:srgbClr val="5C6690"/>
+                </a:solidFill>
+                <a:latin typeface="Calibri" pitchFamily="34" charset="0"/>
+                <a:ea typeface="Calibri" pitchFamily="34" charset="-122"/>
+                <a:cs typeface="Calibri" pitchFamily="34" charset="-120"/>
+              </a:rPr>
+              <a:t>кто</a:t>
+            </a:r>
+            <a:endParaRPr lang="en-US" sz="1500" dirty="0"/>
+          </a:p>
+        </p:txBody>
+      </p:sp>
+      <p:sp>
+        <p:nvSpPr>
+          <p:cNvPr id="33" name="Shape 31"/>
+          <p:cNvSpPr/>
+          <p:nvPr/>
+        </p:nvSpPr>
+        <p:spPr>
+          <a:xfrm>
+            <a:off x="4312920" y="4855464"/>
+            <a:ext cx="3563112" cy="1371600"/>
+          </a:xfrm>
+          <a:prstGeom prst="roundRect">
+            <a:avLst>
+              <a:gd name="adj" fmla="val 6000"/>
+            </a:avLst>
+          </a:prstGeom>
+          <a:solidFill>
+            <a:srgbClr val="F5F6FB"/>
+          </a:solidFill>
+          <a:ln/>
+          <a:effectLst>
+            <a:outerShdw sx="100000" sy="100000" kx="0" ky="0" algn="bl" rotWithShape="0" blurRad="76200" dist="38100" dir="5400000">
+              <a:srgbClr val="1B2340">
+                <a:alpha val="18000"/>
+              </a:srgbClr>
+            </a:outerShdw>
+          </a:effectLst>
+        </p:spPr>
+      </p:sp>
+      <p:sp>
+        <p:nvSpPr>
+          <p:cNvPr id="34" name="Shape 32"/>
+          <p:cNvSpPr/>
+          <p:nvPr/>
+        </p:nvSpPr>
+        <p:spPr>
+          <a:xfrm>
+            <a:off x="4440936" y="5285232"/>
+            <a:ext cx="512064" cy="512064"/>
+          </a:xfrm>
+          <a:prstGeom prst="ellipse">
+            <a:avLst/>
+          </a:prstGeom>
+          <a:solidFill>
+            <a:srgbClr val="F96167"/>
+          </a:solidFill>
+          <a:ln/>
+        </p:spPr>
+      </p:sp>
+      <p:sp>
+        <p:nvSpPr>
+          <p:cNvPr id="35" name="Text 33"/>
+          <p:cNvSpPr/>
+          <p:nvPr/>
+        </p:nvSpPr>
+        <p:spPr>
+          <a:xfrm>
+            <a:off x="4440936" y="5285232"/>
+            <a:ext cx="512064" cy="512064"/>
+          </a:xfrm>
+          <a:prstGeom prst="rect">
+            <a:avLst/>
+          </a:prstGeom>
+          <a:noFill/>
+          <a:ln/>
+        </p:spPr>
+        <p:txBody>
+          <a:bodyPr wrap="square" lIns="0" tIns="0" rIns="0" bIns="0" rtlCol="0" anchor="ctr"/>
+          <a:lstStyle/>
+          <a:p>
+            <a:pPr algn="ctr" indent="0" marL="0">
+              <a:buNone/>
+            </a:pPr>
+            <a:r>
+              <a:rPr lang="en-US" sz="1900" dirty="0">
+                <a:solidFill>
+                  <a:srgbClr val="000000"/>
+                </a:solidFill>
+              </a:rPr>
               <a:t>🔢</a:t>
             </a:r>
-            <a:endParaRPr lang="en-US" sz="2100" dirty="0"/>
-          </a:p>
-        </p:txBody>
-      </p:sp>
-      <p:sp>
-        <p:nvSpPr>
-          <p:cNvPr id="28" name="Text 26"/>
-          <p:cNvSpPr/>
-          <p:nvPr/>
-        </p:nvSpPr>
-        <p:spPr>
-          <a:xfrm>
-            <a:off x="8900160" y="4123944"/>
-            <a:ext cx="2630424" cy="1371600"/>
+            <a:endParaRPr lang="en-US" sz="1900" dirty="0"/>
+          </a:p>
+        </p:txBody>
+      </p:sp>
+      <p:sp>
+        <p:nvSpPr>
+          <p:cNvPr id="36" name="Text 34"/>
+          <p:cNvSpPr/>
+          <p:nvPr/>
+        </p:nvSpPr>
+        <p:spPr>
+          <a:xfrm>
+            <a:off x="5081016" y="4901184"/>
+            <a:ext cx="2685288" cy="1280160"/>
           </a:xfrm>
           <a:prstGeom prst="rect">
             <a:avLst/>
@@ -21133,7 +21817,7 @@
               <a:buNone/>
             </a:pPr>
             <a:r>
-              <a:rPr lang="en-US" sz="1700" b="1" dirty="0">
+              <a:rPr lang="en-US" sz="1500" b="1" dirty="0">
                 <a:solidFill>
                   <a:srgbClr val="2F3C7E"/>
                 </a:solidFill>
@@ -21143,7 +21827,7 @@
               </a:rPr>
               <a:t>cuánto/a/os/as</a:t>
             </a:r>
-            <a:endParaRPr lang="en-US" sz="1700" dirty="0"/>
+            <a:endParaRPr lang="en-US" sz="1500" dirty="0"/>
           </a:p>
           <a:p>
             <a:pPr indent="0" marL="0">
@@ -21153,7 +21837,7 @@
               <a:buNone/>
             </a:pPr>
             <a:r>
-              <a:rPr lang="en-US" sz="1200" dirty="0">
+              <a:rPr lang="en-US" sz="1100" dirty="0">
                 <a:solidFill>
                   <a:srgbClr val="5C6690"/>
                 </a:solidFill>
@@ -21163,13 +21847,13 @@
               </a:rPr>
               <a:t>сколько</a:t>
             </a:r>
-            <a:endParaRPr lang="en-US" sz="1700" dirty="0"/>
-          </a:p>
-        </p:txBody>
-      </p:sp>
-      <p:sp>
-        <p:nvSpPr>
-          <p:cNvPr id="29" name="Text 27"/>
+            <a:endParaRPr lang="en-US" sz="1500" dirty="0"/>
+          </a:p>
+        </p:txBody>
+      </p:sp>
+      <p:sp>
+        <p:nvSpPr>
+          <p:cNvPr id="37" name="Text 35"/>
           <p:cNvSpPr/>
           <p:nvPr/>
         </p:nvSpPr>
@@ -21203,6 +21887,45 @@
               <a:t>Nuevo Español en Marcha 1 · Unidad 1 · Vocabulario visual</a:t>
             </a:r>
             <a:endParaRPr lang="en-US" sz="1000" dirty="0"/>
+          </a:p>
+        </p:txBody>
+      </p:sp>
+      <p:sp>
+        <p:nvSpPr>
+          <p:cNvPr id="38" name="Text 36"/>
+          <p:cNvSpPr/>
+          <p:nvPr/>
+        </p:nvSpPr>
+        <p:spPr>
+          <a:xfrm>
+            <a:off x="7985455" y="6473952"/>
+            <a:ext cx="3657600" cy="274320"/>
+          </a:xfrm>
+          <a:prstGeom prst="rect">
+            <a:avLst/>
+          </a:prstGeom>
+          <a:noFill/>
+          <a:ln/>
+        </p:spPr>
+        <p:txBody>
+          <a:bodyPr wrap="square" lIns="0" tIns="0" rIns="0" bIns="0" rtlCol="0" anchor="ctr"/>
+          <a:lstStyle/>
+          <a:p>
+            <a:pPr algn="r" indent="0" marL="0">
+              <a:buNone/>
+            </a:pPr>
+            <a:r>
+              <a:rPr lang="en-US" sz="900" dirty="0">
+                <a:solidFill>
+                  <a:srgbClr val="5C6690"/>
+                </a:solidFill>
+                <a:latin typeface="Calibri" pitchFamily="34" charset="0"/>
+                <a:ea typeface="Calibri" pitchFamily="34" charset="-122"/>
+                <a:cs typeface="Calibri" pitchFamily="34" charset="-120"/>
+              </a:rPr>
+              <a:t>© Ángel Luis Acosta González</a:t>
+            </a:r>
+            <a:endParaRPr lang="en-US" sz="900" dirty="0"/>
           </a:p>
         </p:txBody>
       </p:sp>
@@ -22423,6 +23146,45 @@
           </a:p>
         </p:txBody>
       </p:sp>
+      <p:sp>
+        <p:nvSpPr>
+          <p:cNvPr id="34" name="Text 32"/>
+          <p:cNvSpPr/>
+          <p:nvPr/>
+        </p:nvSpPr>
+        <p:spPr>
+          <a:xfrm>
+            <a:off x="7985455" y="6473952"/>
+            <a:ext cx="3657600" cy="274320"/>
+          </a:xfrm>
+          <a:prstGeom prst="rect">
+            <a:avLst/>
+          </a:prstGeom>
+          <a:noFill/>
+          <a:ln/>
+        </p:spPr>
+        <p:txBody>
+          <a:bodyPr wrap="square" lIns="0" tIns="0" rIns="0" bIns="0" rtlCol="0" anchor="ctr"/>
+          <a:lstStyle/>
+          <a:p>
+            <a:pPr algn="r" indent="0" marL="0">
+              <a:buNone/>
+            </a:pPr>
+            <a:r>
+              <a:rPr lang="en-US" sz="900" dirty="0">
+                <a:solidFill>
+                  <a:srgbClr val="5C6690"/>
+                </a:solidFill>
+                <a:latin typeface="Calibri" pitchFamily="34" charset="0"/>
+                <a:ea typeface="Calibri" pitchFamily="34" charset="-122"/>
+                <a:cs typeface="Calibri" pitchFamily="34" charset="-120"/>
+              </a:rPr>
+              <a:t>© Ángel Luis Acosta González</a:t>
+            </a:r>
+            <a:endParaRPr lang="en-US" sz="900" dirty="0"/>
+          </a:p>
+        </p:txBody>
+      </p:sp>
     </p:spTree>
   </p:cSld>
   <p:clrMapOvr>
@@ -23787,6 +24549,45 @@
           </a:p>
         </p:txBody>
       </p:sp>
+      <p:sp>
+        <p:nvSpPr>
+          <p:cNvPr id="38" name="Text 36"/>
+          <p:cNvSpPr/>
+          <p:nvPr/>
+        </p:nvSpPr>
+        <p:spPr>
+          <a:xfrm>
+            <a:off x="7985455" y="6473952"/>
+            <a:ext cx="3657600" cy="274320"/>
+          </a:xfrm>
+          <a:prstGeom prst="rect">
+            <a:avLst/>
+          </a:prstGeom>
+          <a:noFill/>
+          <a:ln/>
+        </p:spPr>
+        <p:txBody>
+          <a:bodyPr wrap="square" lIns="0" tIns="0" rIns="0" bIns="0" rtlCol="0" anchor="ctr"/>
+          <a:lstStyle/>
+          <a:p>
+            <a:pPr algn="r" indent="0" marL="0">
+              <a:buNone/>
+            </a:pPr>
+            <a:r>
+              <a:rPr lang="en-US" sz="900" dirty="0">
+                <a:solidFill>
+                  <a:srgbClr val="5C6690"/>
+                </a:solidFill>
+                <a:latin typeface="Calibri" pitchFamily="34" charset="0"/>
+                <a:ea typeface="Calibri" pitchFamily="34" charset="-122"/>
+                <a:cs typeface="Calibri" pitchFamily="34" charset="-120"/>
+              </a:rPr>
+              <a:t>© Ángel Luis Acosta González</a:t>
+            </a:r>
+            <a:endParaRPr lang="en-US" sz="900" dirty="0"/>
+          </a:p>
+        </p:txBody>
+      </p:sp>
     </p:spTree>
   </p:cSld>
   <p:clrMapOvr>
@@ -25886,6 +26687,45 @@
           </a:p>
         </p:txBody>
       </p:sp>
+      <p:sp>
+        <p:nvSpPr>
+          <p:cNvPr id="58" name="Text 56"/>
+          <p:cNvSpPr/>
+          <p:nvPr/>
+        </p:nvSpPr>
+        <p:spPr>
+          <a:xfrm>
+            <a:off x="7985455" y="6473952"/>
+            <a:ext cx="3657600" cy="274320"/>
+          </a:xfrm>
+          <a:prstGeom prst="rect">
+            <a:avLst/>
+          </a:prstGeom>
+          <a:noFill/>
+          <a:ln/>
+        </p:spPr>
+        <p:txBody>
+          <a:bodyPr wrap="square" lIns="0" tIns="0" rIns="0" bIns="0" rtlCol="0" anchor="ctr"/>
+          <a:lstStyle/>
+          <a:p>
+            <a:pPr algn="r" indent="0" marL="0">
+              <a:buNone/>
+            </a:pPr>
+            <a:r>
+              <a:rPr lang="en-US" sz="900" dirty="0">
+                <a:solidFill>
+                  <a:srgbClr val="5C6690"/>
+                </a:solidFill>
+                <a:latin typeface="Calibri" pitchFamily="34" charset="0"/>
+                <a:ea typeface="Calibri" pitchFamily="34" charset="-122"/>
+                <a:cs typeface="Calibri" pitchFamily="34" charset="-120"/>
+              </a:rPr>
+              <a:t>© Ángel Luis Acosta González</a:t>
+            </a:r>
+            <a:endParaRPr lang="en-US" sz="900" dirty="0"/>
+          </a:p>
+        </p:txBody>
+      </p:sp>
     </p:spTree>
   </p:cSld>
   <p:clrMapOvr>
@@ -27982,6 +28822,45 @@
               <a:t>Nuevo Español en Marcha 1 · Unidad 1 · Vocabulario visual</a:t>
             </a:r>
             <a:endParaRPr lang="en-US" sz="1000" dirty="0"/>
+          </a:p>
+        </p:txBody>
+      </p:sp>
+      <p:sp>
+        <p:nvSpPr>
+          <p:cNvPr id="58" name="Text 56"/>
+          <p:cNvSpPr/>
+          <p:nvPr/>
+        </p:nvSpPr>
+        <p:spPr>
+          <a:xfrm>
+            <a:off x="7985455" y="6473952"/>
+            <a:ext cx="3657600" cy="274320"/>
+          </a:xfrm>
+          <a:prstGeom prst="rect">
+            <a:avLst/>
+          </a:prstGeom>
+          <a:noFill/>
+          <a:ln/>
+        </p:spPr>
+        <p:txBody>
+          <a:bodyPr wrap="square" lIns="0" tIns="0" rIns="0" bIns="0" rtlCol="0" anchor="ctr"/>
+          <a:lstStyle/>
+          <a:p>
+            <a:pPr algn="r" indent="0" marL="0">
+              <a:buNone/>
+            </a:pPr>
+            <a:r>
+              <a:rPr lang="en-US" sz="900" dirty="0">
+                <a:solidFill>
+                  <a:srgbClr val="5C6690"/>
+                </a:solidFill>
+                <a:latin typeface="Calibri" pitchFamily="34" charset="0"/>
+                <a:ea typeface="Calibri" pitchFamily="34" charset="-122"/>
+                <a:cs typeface="Calibri" pitchFamily="34" charset="-120"/>
+              </a:rPr>
+              <a:t>© Ángel Luis Acosta González</a:t>
+            </a:r>
+            <a:endParaRPr lang="en-US" sz="900" dirty="0"/>
           </a:p>
         </p:txBody>
       </p:sp>

</xml_diff>